<commit_message>
Refresh unbranded retrieval templates and link readable research summaries
</commit_message>
<xml_diff>
--- a/public/retrieval-brain-dump-template.pptx
+++ b/public/retrieval-brain-dump-template.pptx
@@ -2,13 +2,13 @@
 <file path=ppt/presentation.xml><?xml version="1.0" encoding="utf-8"?>
 <p:presentation xmlns:p="http://schemas.openxmlformats.org/presentationml/2006/main">
   <p:sldMasterIdLst>
-    <p:sldMasterId xmlns:r="http://schemas.openxmlformats.org/officeDocument/2006/relationships" id="2147483648" r:id="R2bd6c9d713c34c63"/>
+    <p:sldMasterId xmlns:r="http://schemas.openxmlformats.org/officeDocument/2006/relationships" id="2147483648" r:id="Rddb6f3cfb90b4264"/>
   </p:sldMasterIdLst>
   <p:notesMasterIdLst>
-    <p:notesMasterId xmlns:r="http://schemas.openxmlformats.org/officeDocument/2006/relationships" r:id="R1953d27fedbc4540"/>
+    <p:notesMasterId xmlns:r="http://schemas.openxmlformats.org/officeDocument/2006/relationships" r:id="R111723cb49c14786"/>
   </p:notesMasterIdLst>
   <p:sldIdLst>
-    <p:sldId xmlns:r="http://schemas.openxmlformats.org/officeDocument/2006/relationships" id="256" r:id="R72b72c815a8d4648"/>
+    <p:sldId xmlns:r="http://schemas.openxmlformats.org/officeDocument/2006/relationships" id="256" r:id="Raf3ce8b446d8421c"/>
   </p:sldIdLst>
   <p:sldSz cx="12192000" cy="6858000"/>
   <p:notesSz cx="6858000" cy="9144000"/>
@@ -442,7 +442,7 @@
           <a:lstStyle xmlns:a="http://schemas.openxmlformats.org/drawingml/2006/main"/>
           <a:p xmlns:a="http://schemas.openxmlformats.org/drawingml/2006/main">
             <a:r>
-              <a:t>Teacher setup: Replace bracketed text before teaching. Every text box is editable. Duplicate the slide for checked answers or a second prompt. Keep prompt and answer sides separate when printing cards.</a:t>
+              <a:t>Teacher setup: Replace bracketed text before teaching. All text and shapes are editable. Duplicate the slide for answers or another prompt. For card activities, separate prompt and answer sides before printing.</a:t>
             </a:r>
           </a:p>
           <a:p xmlns:a="http://schemas.openxmlformats.org/drawingml/2006/main">
@@ -452,17 +452,12 @@
           </a:p>
           <a:p xmlns:a="http://schemas.openxmlformats.org/drawingml/2006/main">
             <a:r>
-              <a:t>Activity: Brain dump</a:t>
-            </a:r>
-          </a:p>
-          <a:p xmlns:a="http://schemas.openxmlformats.org/drawingml/2006/main">
-            <a:r>
               <a:t>Materials: Paper or mini whiteboards</a:t>
             </a:r>
           </a:p>
           <a:p xmlns:a="http://schemas.openxmlformats.org/drawingml/2006/main">
             <a:r>
-              <a:t>Suggested total time including feedback: 5 minutes.</a:t>
+              <a:t>Suggested time including feedback: 5 minutes.</a:t>
             </a:r>
           </a:p>
           <a:p xmlns:a="http://schemas.openxmlformats.org/drawingml/2006/main">
@@ -503,26 +498,6 @@
           <a:p xmlns:a="http://schemas.openxmlformats.org/drawingml/2006/main">
             <a:r>
               <a:t>Adapt: Use broad headings if a blank page feels overwhelming; allow spoken recording or labelled sketches.</a:t>
-            </a:r>
-          </a:p>
-          <a:p xmlns:a="http://schemas.openxmlformats.org/drawingml/2006/main">
-            <a:r>
-              <a:t>Credit: Pooja K. Agarwal — classroom guidance</a:t>
-            </a:r>
-          </a:p>
-          <a:p xmlns:a="http://schemas.openxmlformats.org/drawingml/2006/main">
-            <a:r>
-              <a:t>Free recall is a longstanding research method. Credit here recognises Agarwal’s classroom explanation, rather than claiming she invented free recall.</a:t>
-            </a:r>
-          </a:p>
-          <a:p xmlns:a="http://schemas.openxmlformats.org/drawingml/2006/main">
-            <a:r>
-              <a:t>Source: https://www.retrievalpractice.org/strategies/2017/free-recall</a:t>
-            </a:r>
-          </a:p>
-          <a:p xmlns:a="http://schemas.openxmlformats.org/drawingml/2006/main">
-            <a:r>
-              <a:t>Full guide: https://tnt-teaching-tools.github.io/cold-call-classroom/retrieval-brain-dump.html</a:t>
             </a:r>
           </a:p>
         </p:txBody>
@@ -569,7 +544,7 @@
           <p:cNvPr id="4" name="Accent rule">
             <a:extLst xmlns:a="http://schemas.openxmlformats.org/drawingml/2006/main">
               <a:ext uri="{FF2B5EF4-FFF2-40B4-BE49-F238E27FC236}">
-                <a16:creationId xmlns:a16="http://schemas.microsoft.com/office/drawing/2014/main" id="{0C0A18D5-C81E-4FFF-8551-00E834E30C90}"/>
+                <a16:creationId xmlns:a16="http://schemas.microsoft.com/office/drawing/2014/main" id="{F1C421B9-2701-4A5C-A3A0-198090727923}"/>
               </a:ext>
             </a:extLst>
           </p:cNvPr>
@@ -600,7 +575,7 @@
           <p:cNvPr id="2" name="Title">
             <a:extLst xmlns:a="http://schemas.openxmlformats.org/drawingml/2006/main">
               <a:ext uri="{FF2B5EF4-FFF2-40B4-BE49-F238E27FC236}">
-                <a16:creationId xmlns:a16="http://schemas.microsoft.com/office/drawing/2014/main" id="{565214C6-3A8D-4BE7-8482-77D0F43F73C3}"/>
+                <a16:creationId xmlns:a16="http://schemas.microsoft.com/office/drawing/2014/main" id="{54C4E6E3-F346-488A-BFA4-6C6109719D80}"/>
               </a:ext>
             </a:extLst>
           </p:cNvPr>
@@ -747,7 +722,7 @@
           <p:cNvPr id="3" name="Subtitle">
             <a:extLst xmlns:a="http://schemas.openxmlformats.org/drawingml/2006/main">
               <a:ext uri="{FF2B5EF4-FFF2-40B4-BE49-F238E27FC236}">
-                <a16:creationId xmlns:a16="http://schemas.microsoft.com/office/drawing/2014/main" id="{BA32AB4F-26E0-4602-9F10-D840A7A775B6}"/>
+                <a16:creationId xmlns:a16="http://schemas.microsoft.com/office/drawing/2014/main" id="{25C6F8FC-7829-4F7F-949F-168AD2EE5736}"/>
               </a:ext>
             </a:extLst>
           </p:cNvPr>
@@ -911,7 +886,7 @@
           <p:cNvPr id="3" name="Accent rule">
             <a:extLst xmlns:a="http://schemas.openxmlformats.org/drawingml/2006/main">
               <a:ext uri="{FF2B5EF4-FFF2-40B4-BE49-F238E27FC236}">
-                <a16:creationId xmlns:a16="http://schemas.microsoft.com/office/drawing/2014/main" id="{BA59E55D-1DD6-449A-B2FE-996BDE0E356E}"/>
+                <a16:creationId xmlns:a16="http://schemas.microsoft.com/office/drawing/2014/main" id="{E727AF49-C4D4-4C42-916D-EBBE5CB616AE}"/>
               </a:ext>
             </a:extLst>
           </p:cNvPr>
@@ -942,7 +917,7 @@
           <p:cNvPr id="2" name="Section title">
             <a:extLst xmlns:a="http://schemas.openxmlformats.org/drawingml/2006/main">
               <a:ext uri="{FF2B5EF4-FFF2-40B4-BE49-F238E27FC236}">
-                <a16:creationId xmlns:a16="http://schemas.microsoft.com/office/drawing/2014/main" id="{6DE647F5-0B1B-4454-AA29-43DF1775168B}"/>
+                <a16:creationId xmlns:a16="http://schemas.microsoft.com/office/drawing/2014/main" id="{145651D3-979F-412B-88D8-D96382D98EF7}"/>
               </a:ext>
             </a:extLst>
           </p:cNvPr>
@@ -1106,7 +1081,7 @@
           <p:cNvPr id="4" name="Accent rule">
             <a:extLst xmlns:a="http://schemas.openxmlformats.org/drawingml/2006/main">
               <a:ext uri="{FF2B5EF4-FFF2-40B4-BE49-F238E27FC236}">
-                <a16:creationId xmlns:a16="http://schemas.microsoft.com/office/drawing/2014/main" id="{ED73F140-814A-4908-83EF-8D1CE0CDC9CB}"/>
+                <a16:creationId xmlns:a16="http://schemas.microsoft.com/office/drawing/2014/main" id="{85DF76C0-95E3-4D3C-8560-4E2C82DD6584}"/>
               </a:ext>
             </a:extLst>
           </p:cNvPr>
@@ -1137,7 +1112,7 @@
           <p:cNvPr id="2" name="Title">
             <a:extLst xmlns:a="http://schemas.openxmlformats.org/drawingml/2006/main">
               <a:ext uri="{FF2B5EF4-FFF2-40B4-BE49-F238E27FC236}">
-                <a16:creationId xmlns:a16="http://schemas.microsoft.com/office/drawing/2014/main" id="{01A37C63-A52E-4559-8FA9-DB22BB4D64E6}"/>
+                <a16:creationId xmlns:a16="http://schemas.microsoft.com/office/drawing/2014/main" id="{D9CDB5F3-43A5-4270-87B3-5A655F9A73E5}"/>
               </a:ext>
             </a:extLst>
           </p:cNvPr>
@@ -1284,7 +1259,7 @@
           <p:cNvPr id="3" name="Body">
             <a:extLst xmlns:a="http://schemas.openxmlformats.org/drawingml/2006/main">
               <a:ext uri="{FF2B5EF4-FFF2-40B4-BE49-F238E27FC236}">
-                <a16:creationId xmlns:a16="http://schemas.microsoft.com/office/drawing/2014/main" id="{A7882EE6-673B-4AF1-BE9B-539B4853613F}"/>
+                <a16:creationId xmlns:a16="http://schemas.microsoft.com/office/drawing/2014/main" id="{B3C66EA9-B7D5-4FC5-A73F-E342BD9DCE1F}"/>
               </a:ext>
             </a:extLst>
           </p:cNvPr>
@@ -1448,7 +1423,7 @@
           <p:cNvPr id="5" name="Accent rule">
             <a:extLst xmlns:a="http://schemas.openxmlformats.org/drawingml/2006/main">
               <a:ext uri="{FF2B5EF4-FFF2-40B4-BE49-F238E27FC236}">
-                <a16:creationId xmlns:a16="http://schemas.microsoft.com/office/drawing/2014/main" id="{0BB1976D-B62B-49EF-A879-F1DE0B6BCFB9}"/>
+                <a16:creationId xmlns:a16="http://schemas.microsoft.com/office/drawing/2014/main" id="{C2BED7CE-1CA2-4CEA-ADC5-9DA29FAEB9DE}"/>
               </a:ext>
             </a:extLst>
           </p:cNvPr>
@@ -1479,7 +1454,7 @@
           <p:cNvPr id="2" name="Title">
             <a:extLst xmlns:a="http://schemas.openxmlformats.org/drawingml/2006/main">
               <a:ext uri="{FF2B5EF4-FFF2-40B4-BE49-F238E27FC236}">
-                <a16:creationId xmlns:a16="http://schemas.microsoft.com/office/drawing/2014/main" id="{D0A5A4BE-8079-4554-AC25-31BCE0A5FB7E}"/>
+                <a16:creationId xmlns:a16="http://schemas.microsoft.com/office/drawing/2014/main" id="{0F9681FD-1D6D-4026-950F-6DCFBA2E3ED2}"/>
               </a:ext>
             </a:extLst>
           </p:cNvPr>
@@ -1626,7 +1601,7 @@
           <p:cNvPr id="3" name="Left column">
             <a:extLst xmlns:a="http://schemas.openxmlformats.org/drawingml/2006/main">
               <a:ext uri="{FF2B5EF4-FFF2-40B4-BE49-F238E27FC236}">
-                <a16:creationId xmlns:a16="http://schemas.microsoft.com/office/drawing/2014/main" id="{02AD53B9-FCC7-4422-9314-0CEFDAA1D7F3}"/>
+                <a16:creationId xmlns:a16="http://schemas.microsoft.com/office/drawing/2014/main" id="{24684C84-7879-4671-9942-A28F2A5A6FC2}"/>
               </a:ext>
             </a:extLst>
           </p:cNvPr>
@@ -1773,7 +1748,7 @@
           <p:cNvPr id="4" name="Right column">
             <a:extLst xmlns:a="http://schemas.openxmlformats.org/drawingml/2006/main">
               <a:ext uri="{FF2B5EF4-FFF2-40B4-BE49-F238E27FC236}">
-                <a16:creationId xmlns:a16="http://schemas.microsoft.com/office/drawing/2014/main" id="{278CFCA4-A33F-4704-A527-FB4B99B2C60D}"/>
+                <a16:creationId xmlns:a16="http://schemas.microsoft.com/office/drawing/2014/main" id="{64AA538A-2CEE-4D05-96C6-F4928CED08BC}"/>
               </a:ext>
             </a:extLst>
           </p:cNvPr>
@@ -1937,7 +1912,7 @@
           <p:cNvPr id="4" name="Accent rule">
             <a:extLst xmlns:a="http://schemas.openxmlformats.org/drawingml/2006/main">
               <a:ext uri="{FF2B5EF4-FFF2-40B4-BE49-F238E27FC236}">
-                <a16:creationId xmlns:a16="http://schemas.microsoft.com/office/drawing/2014/main" id="{830E75A0-77A2-470E-B31B-CCA6913DDF26}"/>
+                <a16:creationId xmlns:a16="http://schemas.microsoft.com/office/drawing/2014/main" id="{44133AA0-494C-4B4B-A3DB-6EF58AA83C5E}"/>
               </a:ext>
             </a:extLst>
           </p:cNvPr>
@@ -1968,7 +1943,7 @@
           <p:cNvPr id="2" name="Title">
             <a:extLst xmlns:a="http://schemas.openxmlformats.org/drawingml/2006/main">
               <a:ext uri="{FF2B5EF4-FFF2-40B4-BE49-F238E27FC236}">
-                <a16:creationId xmlns:a16="http://schemas.microsoft.com/office/drawing/2014/main" id="{7EA42554-7152-4DD8-A688-A55BBA050BF9}"/>
+                <a16:creationId xmlns:a16="http://schemas.microsoft.com/office/drawing/2014/main" id="{EDC145FB-4911-431E-ABB7-726A85AEFFAB}"/>
               </a:ext>
             </a:extLst>
           </p:cNvPr>
@@ -2115,7 +2090,7 @@
           <p:cNvPr id="3" name="Left column">
             <a:extLst xmlns:a="http://schemas.openxmlformats.org/drawingml/2006/main">
               <a:ext uri="{FF2B5EF4-FFF2-40B4-BE49-F238E27FC236}">
-                <a16:creationId xmlns:a16="http://schemas.microsoft.com/office/drawing/2014/main" id="{151C94E7-60C9-483D-8833-7A5AA83F95D1}"/>
+                <a16:creationId xmlns:a16="http://schemas.microsoft.com/office/drawing/2014/main" id="{812F40D8-B925-4C19-A3CD-4B54EA972023}"/>
               </a:ext>
             </a:extLst>
           </p:cNvPr>
@@ -2300,12 +2275,12 @@
   </p:cSld>
   <p:clrMap bg1="lt1" tx1="dk1" bg2="lt2" tx2="dk2" accent1="accent1" accent2="accent2" accent3="accent3" accent4="accent4" accent5="accent5" accent6="accent6" hlink="hlink" folHlink="folHlink"/>
   <p:sldLayoutIdLst>
-    <p:sldLayoutId xmlns:r="http://schemas.openxmlformats.org/officeDocument/2006/relationships" id="2147483649" r:id="R0e207fd5eba84761"/>
-    <p:sldLayoutId xmlns:r="http://schemas.openxmlformats.org/officeDocument/2006/relationships" id="2147483650" r:id="R691e7eba916048de"/>
-    <p:sldLayoutId xmlns:r="http://schemas.openxmlformats.org/officeDocument/2006/relationships" id="2147483651" r:id="R9f25cd9adaa04bd0"/>
-    <p:sldLayoutId xmlns:r="http://schemas.openxmlformats.org/officeDocument/2006/relationships" id="2147483652" r:id="R3f82cf96fef04ece"/>
-    <p:sldLayoutId xmlns:r="http://schemas.openxmlformats.org/officeDocument/2006/relationships" id="2147483653" r:id="R68a7ae31d0844285"/>
-    <p:sldLayoutId xmlns:r="http://schemas.openxmlformats.org/officeDocument/2006/relationships" id="2147483654" r:id="R5bd30da616a54a4a"/>
+    <p:sldLayoutId xmlns:r="http://schemas.openxmlformats.org/officeDocument/2006/relationships" id="2147483649" r:id="Redb4e5b5e6f2432a"/>
+    <p:sldLayoutId xmlns:r="http://schemas.openxmlformats.org/officeDocument/2006/relationships" id="2147483650" r:id="Rd72e0b2455d347b3"/>
+    <p:sldLayoutId xmlns:r="http://schemas.openxmlformats.org/officeDocument/2006/relationships" id="2147483651" r:id="Re1c64a2866e04520"/>
+    <p:sldLayoutId xmlns:r="http://schemas.openxmlformats.org/officeDocument/2006/relationships" id="2147483652" r:id="R239a025c0fb04297"/>
+    <p:sldLayoutId xmlns:r="http://schemas.openxmlformats.org/officeDocument/2006/relationships" id="2147483653" r:id="R3c1df101ee0e4301"/>
+    <p:sldLayoutId xmlns:r="http://schemas.openxmlformats.org/officeDocument/2006/relationships" id="2147483654" r:id="R620d483691994c0c"/>
   </p:sldLayoutIdLst>
   <p:txStyles>
     <p:titleStyle>
@@ -2838,7 +2813,7 @@
     <p:bg>
       <p:bgPr>
         <a:solidFill xmlns:a="http://schemas.openxmlformats.org/drawingml/2006/main">
-          <a:srgbClr val="FFFCF2"/>
+          <a:srgbClr val="FFFDF5"/>
         </a:solidFill>
       </p:bgPr>
     </p:bg>
@@ -2853,10 +2828,10 @@
       </p:grpSpPr>
       <p:sp>
         <p:nvSpPr>
-          <p:cNvPr id="8" name="">
+          <p:cNvPr id="15" name="">
             <a:extLst xmlns:a="http://schemas.openxmlformats.org/drawingml/2006/main">
               <a:ext uri="{FF2B5EF4-FFF2-40B4-BE49-F238E27FC236}">
-                <a16:creationId xmlns:a16="http://schemas.microsoft.com/office/drawing/2014/main" id="{F2EB50BA-C8FF-4249-B902-F8EA30A0B6AD}"/>
+                <a16:creationId xmlns:a16="http://schemas.microsoft.com/office/drawing/2014/main" id="{A847B1AF-89C5-4A67-B943-D3CB70A8114E}"/>
               </a:ext>
             </a:extLst>
           </p:cNvPr>
@@ -2867,235 +2842,7 @@
         </p:nvSpPr>
         <p:spPr>
           <a:xfrm xmlns:a="http://schemas.openxmlformats.org/drawingml/2006/main">
-            <a:off x="609600" y="333375"/>
-            <a:ext cx="10972800" cy="714375"/>
-          </a:xfrm>
-          <a:prstGeom xmlns:a="http://schemas.openxmlformats.org/drawingml/2006/main" prst="rect">
-            <a:avLst/>
-          </a:prstGeom>
-          <a:noFill xmlns:a="http://schemas.openxmlformats.org/drawingml/2006/main"/>
-          <a:ln xmlns:a="http://schemas.openxmlformats.org/drawingml/2006/main" w="0">
-            <a:noFill/>
-          </a:ln>
-        </p:spPr>
-        <p:txBody>
-          <a:bodyPr xmlns:a="http://schemas.openxmlformats.org/drawingml/2006/main" lIns="0" tIns="0" rIns="0" bIns="0" anchor="t">
-            <a:noAutofit/>
-          </a:bodyPr>
-          <a:lstStyle xmlns:a="http://schemas.openxmlformats.org/drawingml/2006/main"/>
-          <a:p xmlns:a="http://schemas.openxmlformats.org/drawingml/2006/main">
-            <a:pPr>
-              <a:defRPr sz="4050" b="1">
-                <a:solidFill>
-                  <a:srgbClr val="242720"/>
-                </a:solidFill>
-                <a:latin typeface="Arial"/>
-                <a:ea typeface="Arial"/>
-                <a:cs typeface="Arial"/>
-              </a:defRPr>
-            </a:pPr>
-            <a:r>
-              <a:rPr sz="4050" b="1">
-                <a:solidFill>
-                  <a:srgbClr val="242720"/>
-                </a:solidFill>
-                <a:latin typeface="Arial"/>
-                <a:ea typeface="Arial"/>
-                <a:cs typeface="Arial"/>
-              </a:rPr>
-              <a:t>Brain dump</a:t>
-            </a:r>
-          </a:p>
-        </p:txBody>
-      </p:sp>
-      <p:sp>
-        <p:nvSpPr>
-          <p:cNvPr id="2" name="">
-            <a:extLst xmlns:a="http://schemas.openxmlformats.org/drawingml/2006/main">
-              <a:ext uri="{FF2B5EF4-FFF2-40B4-BE49-F238E27FC236}">
-                <a16:creationId xmlns:a16="http://schemas.microsoft.com/office/drawing/2014/main" id="{90B68515-FA3C-4FE2-B7EC-B006CEE5E164}"/>
-              </a:ext>
-            </a:extLst>
-          </p:cNvPr>
-          <p:cNvSpPr>
-            <a:spLocks xmlns:a="http://schemas.openxmlformats.org/drawingml/2006/main" noGrp="1"/>
-          </p:cNvSpPr>
-          <p:nvPr/>
-        </p:nvSpPr>
-        <p:spPr>
-          <a:xfrm xmlns:a="http://schemas.openxmlformats.org/drawingml/2006/main">
-            <a:off x="609600" y="1190625"/>
-            <a:ext cx="10972800" cy="476250"/>
-          </a:xfrm>
-          <a:prstGeom xmlns:a="http://schemas.openxmlformats.org/drawingml/2006/main" prst="rect">
-            <a:avLst/>
-          </a:prstGeom>
-          <a:noFill xmlns:a="http://schemas.openxmlformats.org/drawingml/2006/main"/>
-          <a:ln xmlns:a="http://schemas.openxmlformats.org/drawingml/2006/main" w="0">
-            <a:noFill/>
-          </a:ln>
-        </p:spPr>
-        <p:txBody>
-          <a:bodyPr xmlns:a="http://schemas.openxmlformats.org/drawingml/2006/main" lIns="0" tIns="0" rIns="0" bIns="0" anchor="t">
-            <a:noAutofit/>
-          </a:bodyPr>
-          <a:lstStyle xmlns:a="http://schemas.openxmlformats.org/drawingml/2006/main"/>
-          <a:p xmlns:a="http://schemas.openxmlformats.org/drawingml/2006/main">
-            <a:pPr>
-              <a:defRPr sz="2400" b="0">
-                <a:solidFill>
-                  <a:srgbClr val="242720"/>
-                </a:solidFill>
-                <a:latin typeface="Arial"/>
-                <a:ea typeface="Arial"/>
-                <a:cs typeface="Arial"/>
-              </a:defRPr>
-            </a:pPr>
-            <a:r>
-              <a:rPr sz="2400" b="0">
-                <a:solidFill>
-                  <a:srgbClr val="242720"/>
-                </a:solidFill>
-                <a:latin typeface="Arial"/>
-                <a:ea typeface="Arial"/>
-                <a:cs typeface="Arial"/>
-              </a:rPr>
-              <a:t>[Add your topic or retrieval focus]</a:t>
-            </a:r>
-          </a:p>
-        </p:txBody>
-      </p:sp>
-      <p:sp>
-        <p:nvSpPr>
-          <p:cNvPr id="3" name="">
-            <a:extLst xmlns:a="http://schemas.openxmlformats.org/drawingml/2006/main">
-              <a:ext uri="{FF2B5EF4-FFF2-40B4-BE49-F238E27FC236}">
-                <a16:creationId xmlns:a16="http://schemas.microsoft.com/office/drawing/2014/main" id="{3A675FDB-F186-482E-B331-DDC6AECBE745}"/>
-              </a:ext>
-            </a:extLst>
-          </p:cNvPr>
-          <p:cNvSpPr>
-            <a:spLocks xmlns:a="http://schemas.openxmlformats.org/drawingml/2006/main" noGrp="1"/>
-          </p:cNvSpPr>
-          <p:nvPr/>
-        </p:nvSpPr>
-        <p:spPr>
-          <a:xfrm xmlns:a="http://schemas.openxmlformats.org/drawingml/2006/main">
-            <a:off x="609600" y="1733550"/>
-            <a:ext cx="10972800" cy="400050"/>
-          </a:xfrm>
-          <a:prstGeom xmlns:a="http://schemas.openxmlformats.org/drawingml/2006/main" prst="rect">
-            <a:avLst/>
-          </a:prstGeom>
-          <a:noFill xmlns:a="http://schemas.openxmlformats.org/drawingml/2006/main"/>
-          <a:ln xmlns:a="http://schemas.openxmlformats.org/drawingml/2006/main" w="0">
-            <a:noFill/>
-          </a:ln>
-        </p:spPr>
-        <p:txBody>
-          <a:bodyPr xmlns:a="http://schemas.openxmlformats.org/drawingml/2006/main" lIns="0" tIns="0" rIns="0" bIns="0" anchor="t">
-            <a:noAutofit/>
-          </a:bodyPr>
-          <a:lstStyle xmlns:a="http://schemas.openxmlformats.org/drawingml/2006/main"/>
-          <a:p xmlns:a="http://schemas.openxmlformats.org/drawingml/2006/main">
-            <a:pPr>
-              <a:defRPr sz="1800" b="0">
-                <a:solidFill>
-                  <a:srgbClr val="28534A"/>
-                </a:solidFill>
-                <a:latin typeface="Arial"/>
-                <a:ea typeface="Arial"/>
-                <a:cs typeface="Arial"/>
-              </a:defRPr>
-            </a:pPr>
-            <a:r>
-              <a:rPr sz="1800" b="0">
-                <a:solidFill>
-                  <a:srgbClr val="28534A"/>
-                </a:solidFill>
-                <a:latin typeface="Arial"/>
-                <a:ea typeface="Arial"/>
-                <a:cs typeface="Arial"/>
-              </a:rPr>
-              <a:t>Recall independently first. Check and improve after feedback.</a:t>
-            </a:r>
-          </a:p>
-        </p:txBody>
-      </p:sp>
-      <p:sp>
-        <p:nvSpPr>
-          <p:cNvPr id="4" name="">
-            <a:extLst xmlns:a="http://schemas.openxmlformats.org/drawingml/2006/main">
-              <a:ext uri="{FF2B5EF4-FFF2-40B4-BE49-F238E27FC236}">
-                <a16:creationId xmlns:a16="http://schemas.microsoft.com/office/drawing/2014/main" id="{ECDDC86C-E972-4ECB-8806-C18F5789A40A}"/>
-              </a:ext>
-            </a:extLst>
-          </p:cNvPr>
-          <p:cNvSpPr>
-            <a:spLocks xmlns:a="http://schemas.openxmlformats.org/drawingml/2006/main" noGrp="1"/>
-          </p:cNvSpPr>
-          <p:nvPr/>
-        </p:nvSpPr>
-        <p:spPr>
-          <a:xfrm xmlns:a="http://schemas.openxmlformats.org/drawingml/2006/main">
-            <a:off x="609600" y="2524125"/>
-            <a:ext cx="10972800" cy="1905000"/>
-          </a:xfrm>
-          <a:prstGeom xmlns:a="http://schemas.openxmlformats.org/drawingml/2006/main" prst="rect">
-            <a:avLst/>
-          </a:prstGeom>
-          <a:noFill xmlns:a="http://schemas.openxmlformats.org/drawingml/2006/main"/>
-          <a:ln xmlns:a="http://schemas.openxmlformats.org/drawingml/2006/main" w="0">
-            <a:noFill/>
-          </a:ln>
-        </p:spPr>
-        <p:txBody>
-          <a:bodyPr xmlns:a="http://schemas.openxmlformats.org/drawingml/2006/main" lIns="0" tIns="0" rIns="0" bIns="0" anchor="t">
-            <a:noAutofit/>
-          </a:bodyPr>
-          <a:lstStyle xmlns:a="http://schemas.openxmlformats.org/drawingml/2006/main"/>
-          <a:p xmlns:a="http://schemas.openxmlformats.org/drawingml/2006/main">
-            <a:pPr>
-              <a:defRPr sz="2850" b="1">
-                <a:solidFill>
-                  <a:srgbClr val="242720"/>
-                </a:solidFill>
-                <a:latin typeface="Arial"/>
-                <a:ea typeface="Arial"/>
-                <a:cs typeface="Arial"/>
-              </a:defRPr>
-            </a:pPr>
-            <a:r>
-              <a:rPr sz="2850" b="1">
-                <a:solidFill>
-                  <a:srgbClr val="242720"/>
-                </a:solidFill>
-                <a:latin typeface="Arial"/>
-                <a:ea typeface="Arial"/>
-                <a:cs typeface="Arial"/>
-              </a:rPr>
-              <a:t>[Add your recall focus or headings]</a:t>
-            </a:r>
-          </a:p>
-        </p:txBody>
-      </p:sp>
-      <p:sp>
-        <p:nvSpPr>
-          <p:cNvPr id="5" name="">
-            <a:extLst xmlns:a="http://schemas.openxmlformats.org/drawingml/2006/main">
-              <a:ext uri="{FF2B5EF4-FFF2-40B4-BE49-F238E27FC236}">
-                <a16:creationId xmlns:a16="http://schemas.microsoft.com/office/drawing/2014/main" id="{509CB256-7143-4648-9F11-C778349BC6A0}"/>
-              </a:ext>
-            </a:extLst>
-          </p:cNvPr>
-          <p:cNvSpPr>
-            <a:spLocks xmlns:a="http://schemas.openxmlformats.org/drawingml/2006/main" noGrp="1"/>
-          </p:cNvSpPr>
-          <p:nvPr/>
-        </p:nvSpPr>
-        <p:spPr>
-          <a:xfrm xmlns:a="http://schemas.openxmlformats.org/drawingml/2006/main">
-            <a:off x="609600" y="4953000"/>
+            <a:off x="609600" y="323850"/>
             <a:ext cx="10972800" cy="666750"/>
           </a:xfrm>
           <a:prstGeom xmlns:a="http://schemas.openxmlformats.org/drawingml/2006/main" prst="rect">
@@ -3113,35 +2860,35 @@
           <a:lstStyle xmlns:a="http://schemas.openxmlformats.org/drawingml/2006/main"/>
           <a:p xmlns:a="http://schemas.openxmlformats.org/drawingml/2006/main">
             <a:pPr>
-              <a:defRPr sz="2250" b="0">
+              <a:defRPr sz="3450" b="1">
                 <a:solidFill>
-                  <a:srgbClr val="242720"/>
+                  <a:srgbClr val="263C3A"/>
                 </a:solidFill>
-                <a:latin typeface="Arial"/>
-                <a:ea typeface="Arial"/>
-                <a:cs typeface="Arial"/>
+                <a:latin typeface="DejaVu Sans"/>
+                <a:ea typeface="DejaVu Sans"/>
+                <a:cs typeface="DejaVu Sans"/>
               </a:defRPr>
             </a:pPr>
             <a:r>
-              <a:rPr sz="2250" b="0">
+              <a:rPr sz="3450" b="1">
                 <a:solidFill>
-                  <a:srgbClr val="242720"/>
+                  <a:srgbClr val="263C3A"/>
                 </a:solidFill>
-                <a:latin typeface="Arial"/>
-                <a:ea typeface="Arial"/>
-                <a:cs typeface="Arial"/>
+                <a:latin typeface="DejaVu Sans"/>
+                <a:ea typeface="DejaVu Sans"/>
+                <a:cs typeface="DejaVu Sans"/>
               </a:rPr>
-              <a:t>Write or sketch what you remember without notes.</a:t>
+              <a:t>Brain dump</a:t>
             </a:r>
           </a:p>
         </p:txBody>
       </p:sp>
       <p:sp>
         <p:nvSpPr>
-          <p:cNvPr id="6" name="">
+          <p:cNvPr id="2" name="">
             <a:extLst xmlns:a="http://schemas.openxmlformats.org/drawingml/2006/main">
               <a:ext uri="{FF2B5EF4-FFF2-40B4-BE49-F238E27FC236}">
-                <a16:creationId xmlns:a16="http://schemas.microsoft.com/office/drawing/2014/main" id="{C4066C77-0667-4E40-BBD2-BE4FE436744C}"/>
+                <a16:creationId xmlns:a16="http://schemas.microsoft.com/office/drawing/2014/main" id="{523D886D-A8B1-4F93-AED2-A0597733CF8B}"/>
               </a:ext>
             </a:extLst>
           </p:cNvPr>
@@ -3152,8 +2899,8 @@
         </p:nvSpPr>
         <p:spPr>
           <a:xfrm xmlns:a="http://schemas.openxmlformats.org/drawingml/2006/main">
-            <a:off x="609600" y="5953125"/>
-            <a:ext cx="10972800" cy="381000"/>
+            <a:off x="609600" y="1085850"/>
+            <a:ext cx="10972800" cy="409575"/>
           </a:xfrm>
           <a:prstGeom xmlns:a="http://schemas.openxmlformats.org/drawingml/2006/main" prst="rect">
             <a:avLst/>
@@ -3170,35 +2917,35 @@
           <a:lstStyle xmlns:a="http://schemas.openxmlformats.org/drawingml/2006/main"/>
           <a:p xmlns:a="http://schemas.openxmlformats.org/drawingml/2006/main">
             <a:pPr>
-              <a:defRPr sz="1800" b="0">
+              <a:defRPr sz="2175" b="0">
                 <a:solidFill>
-                  <a:srgbClr val="28534A"/>
+                  <a:srgbClr val="687572"/>
                 </a:solidFill>
-                <a:latin typeface="Arial"/>
-                <a:ea typeface="Arial"/>
-                <a:cs typeface="Arial"/>
+                <a:latin typeface="DejaVu Sans"/>
+                <a:ea typeface="DejaVu Sans"/>
+                <a:cs typeface="DejaVu Sans"/>
               </a:defRPr>
             </a:pPr>
             <a:r>
-              <a:rPr sz="1800" b="0">
+              <a:rPr sz="2175" b="0">
                 <a:solidFill>
-                  <a:srgbClr val="28534A"/>
+                  <a:srgbClr val="687572"/>
                 </a:solidFill>
-                <a:latin typeface="Arial"/>
-                <a:ea typeface="Arial"/>
-                <a:cs typeface="Arial"/>
+                <a:latin typeface="DejaVu Sans"/>
+                <a:ea typeface="DejaVu Sans"/>
+                <a:cs typeface="DejaVu Sans"/>
               </a:rPr>
-              <a:t>Time: [Add minutes]     Check: [Add your feedback routine]</a:t>
+              <a:t>[Your topic or retrieval focus]</a:t>
             </a:r>
           </a:p>
         </p:txBody>
       </p:sp>
       <p:sp>
         <p:nvSpPr>
-          <p:cNvPr id="7" name="">
+          <p:cNvPr id="3" name="">
             <a:extLst xmlns:a="http://schemas.openxmlformats.org/drawingml/2006/main">
               <a:ext uri="{FF2B5EF4-FFF2-40B4-BE49-F238E27FC236}">
-                <a16:creationId xmlns:a16="http://schemas.microsoft.com/office/drawing/2014/main" id="{8A6EB708-7ABD-42B4-A8AE-AD9CCE6B4F35}"/>
+                <a16:creationId xmlns:a16="http://schemas.microsoft.com/office/drawing/2014/main" id="{E81DCD6A-F5F3-4629-9B15-475BE4740BC0}"/>
               </a:ext>
             </a:extLst>
           </p:cNvPr>
@@ -3209,8 +2956,38 @@
         </p:nvSpPr>
         <p:spPr>
           <a:xfrm xmlns:a="http://schemas.openxmlformats.org/drawingml/2006/main">
-            <a:off x="609600" y="6534150"/>
-            <a:ext cx="10972800" cy="209550"/>
+            <a:off x="609600" y="1676400"/>
+            <a:ext cx="10972800" cy="19050"/>
+          </a:xfrm>
+          <a:prstGeom xmlns:a="http://schemas.openxmlformats.org/drawingml/2006/main" prst="rect">
+            <a:avLst/>
+          </a:prstGeom>
+          <a:solidFill xmlns:a="http://schemas.openxmlformats.org/drawingml/2006/main">
+            <a:srgbClr val="A9BDB7"/>
+          </a:solidFill>
+          <a:ln xmlns:a="http://schemas.openxmlformats.org/drawingml/2006/main" w="0">
+            <a:noFill/>
+          </a:ln>
+        </p:spPr>
+      </p:sp>
+      <p:sp>
+        <p:nvSpPr>
+          <p:cNvPr id="4" name="">
+            <a:extLst xmlns:a="http://schemas.openxmlformats.org/drawingml/2006/main">
+              <a:ext uri="{FF2B5EF4-FFF2-40B4-BE49-F238E27FC236}">
+                <a16:creationId xmlns:a16="http://schemas.microsoft.com/office/drawing/2014/main" id="{55EE22FC-BD2C-4E95-B3DC-AEDA609A39B9}"/>
+              </a:ext>
+            </a:extLst>
+          </p:cNvPr>
+          <p:cNvSpPr>
+            <a:spLocks xmlns:a="http://schemas.openxmlformats.org/drawingml/2006/main" noGrp="1"/>
+          </p:cNvSpPr>
+          <p:nvPr/>
+        </p:nvSpPr>
+        <p:spPr>
+          <a:xfrm xmlns:a="http://schemas.openxmlformats.org/drawingml/2006/main">
+            <a:off x="609600" y="1828800"/>
+            <a:ext cx="4476750" cy="304800"/>
           </a:xfrm>
           <a:prstGeom xmlns:a="http://schemas.openxmlformats.org/drawingml/2006/main" prst="rect">
             <a:avLst/>
@@ -3227,25 +3004,516 @@
           <a:lstStyle xmlns:a="http://schemas.openxmlformats.org/drawingml/2006/main"/>
           <a:p xmlns:a="http://schemas.openxmlformats.org/drawingml/2006/main">
             <a:pPr>
-              <a:defRPr sz="1050" b="0">
+              <a:defRPr sz="1575" b="1">
                 <a:solidFill>
-                  <a:srgbClr val="62675C"/>
+                  <a:srgbClr val="263C3A"/>
                 </a:solidFill>
-                <a:latin typeface="Arial"/>
-                <a:ea typeface="Arial"/>
-                <a:cs typeface="Arial"/>
+                <a:latin typeface="DejaVu Sans"/>
+                <a:ea typeface="DejaVu Sans"/>
+                <a:cs typeface="DejaVu Sans"/>
               </a:defRPr>
             </a:pPr>
             <a:r>
-              <a:rPr sz="1050" b="0">
+              <a:rPr sz="1575" b="1">
                 <a:solidFill>
-                  <a:srgbClr val="62675C"/>
+                  <a:srgbClr val="263C3A"/>
                 </a:solidFill>
-                <a:latin typeface="Arial"/>
-                <a:ea typeface="Arial"/>
-                <a:cs typeface="Arial"/>
+                <a:latin typeface="DejaVu Sans"/>
+                <a:ea typeface="DejaVu Sans"/>
+                <a:cs typeface="DejaVu Sans"/>
               </a:rPr>
-              <a:t>TNT Teaching Tools   Editable classroom template   Source and teacher guidance in speaker notes</a:t>
+              <a:t>01  Recall from memory</a:t>
+            </a:r>
+          </a:p>
+        </p:txBody>
+      </p:sp>
+      <p:sp>
+        <p:nvSpPr>
+          <p:cNvPr id="5" name="">
+            <a:extLst xmlns:a="http://schemas.openxmlformats.org/drawingml/2006/main">
+              <a:ext uri="{FF2B5EF4-FFF2-40B4-BE49-F238E27FC236}">
+                <a16:creationId xmlns:a16="http://schemas.microsoft.com/office/drawing/2014/main" id="{BC427EFF-E1B3-4864-B732-143E1ADD5E51}"/>
+              </a:ext>
+            </a:extLst>
+          </p:cNvPr>
+          <p:cNvSpPr>
+            <a:spLocks xmlns:a="http://schemas.openxmlformats.org/drawingml/2006/main" noGrp="1"/>
+          </p:cNvSpPr>
+          <p:nvPr/>
+        </p:nvSpPr>
+        <p:spPr>
+          <a:xfrm xmlns:a="http://schemas.openxmlformats.org/drawingml/2006/main">
+            <a:off x="6286500" y="1828800"/>
+            <a:ext cx="5048250" cy="304800"/>
+          </a:xfrm>
+          <a:prstGeom xmlns:a="http://schemas.openxmlformats.org/drawingml/2006/main" prst="rect">
+            <a:avLst/>
+          </a:prstGeom>
+          <a:noFill xmlns:a="http://schemas.openxmlformats.org/drawingml/2006/main"/>
+          <a:ln xmlns:a="http://schemas.openxmlformats.org/drawingml/2006/main" w="0">
+            <a:noFill/>
+          </a:ln>
+        </p:spPr>
+        <p:txBody>
+          <a:bodyPr xmlns:a="http://schemas.openxmlformats.org/drawingml/2006/main" lIns="0" tIns="0" rIns="0" bIns="0" anchor="t">
+            <a:noAutofit/>
+          </a:bodyPr>
+          <a:lstStyle xmlns:a="http://schemas.openxmlformats.org/drawingml/2006/main"/>
+          <a:p xmlns:a="http://schemas.openxmlformats.org/drawingml/2006/main">
+            <a:pPr>
+              <a:defRPr sz="1575" b="1">
+                <a:solidFill>
+                  <a:srgbClr val="263C3A"/>
+                </a:solidFill>
+                <a:latin typeface="DejaVu Sans"/>
+                <a:ea typeface="DejaVu Sans"/>
+                <a:cs typeface="DejaVu Sans"/>
+              </a:defRPr>
+            </a:pPr>
+            <a:r>
+              <a:rPr sz="1575" b="1">
+                <a:solidFill>
+                  <a:srgbClr val="263C3A"/>
+                </a:solidFill>
+                <a:latin typeface="DejaVu Sans"/>
+                <a:ea typeface="DejaVu Sans"/>
+                <a:cs typeface="DejaVu Sans"/>
+              </a:rPr>
+              <a:t>02  Check and improve</a:t>
+            </a:r>
+          </a:p>
+        </p:txBody>
+      </p:sp>
+      <p:sp>
+        <p:nvSpPr>
+          <p:cNvPr id="6" name="">
+            <a:extLst xmlns:a="http://schemas.openxmlformats.org/drawingml/2006/main">
+              <a:ext uri="{FF2B5EF4-FFF2-40B4-BE49-F238E27FC236}">
+                <a16:creationId xmlns:a16="http://schemas.microsoft.com/office/drawing/2014/main" id="{8F5C1B4D-A4A6-4FD4-8DA4-145E233D1477}"/>
+              </a:ext>
+            </a:extLst>
+          </p:cNvPr>
+          <p:cNvSpPr>
+            <a:spLocks xmlns:a="http://schemas.openxmlformats.org/drawingml/2006/main" noGrp="1"/>
+          </p:cNvSpPr>
+          <p:nvPr/>
+        </p:nvSpPr>
+        <p:spPr>
+          <a:xfrm xmlns:a="http://schemas.openxmlformats.org/drawingml/2006/main">
+            <a:off x="609600" y="2247900"/>
+            <a:ext cx="10972800" cy="2762250"/>
+          </a:xfrm>
+          <a:prstGeom xmlns:a="http://schemas.openxmlformats.org/drawingml/2006/main" prst="rect">
+            <a:avLst/>
+          </a:prstGeom>
+          <a:solidFill xmlns:a="http://schemas.openxmlformats.org/drawingml/2006/main">
+            <a:srgbClr val="EDF2F5"/>
+          </a:solidFill>
+          <a:ln xmlns:a="http://schemas.openxmlformats.org/drawingml/2006/main" w="9525">
+            <a:solidFill>
+              <a:srgbClr val="D4DFDB"/>
+            </a:solidFill>
+          </a:ln>
+        </p:spPr>
+      </p:sp>
+      <p:sp>
+        <p:nvSpPr>
+          <p:cNvPr id="7" name="">
+            <a:extLst xmlns:a="http://schemas.openxmlformats.org/drawingml/2006/main">
+              <a:ext uri="{FF2B5EF4-FFF2-40B4-BE49-F238E27FC236}">
+                <a16:creationId xmlns:a16="http://schemas.microsoft.com/office/drawing/2014/main" id="{48AAA147-C814-4756-9A85-0233778F70A3}"/>
+              </a:ext>
+            </a:extLst>
+          </p:cNvPr>
+          <p:cNvSpPr>
+            <a:spLocks xmlns:a="http://schemas.openxmlformats.org/drawingml/2006/main" noGrp="1"/>
+          </p:cNvSpPr>
+          <p:nvPr/>
+        </p:nvSpPr>
+        <p:spPr>
+          <a:xfrm xmlns:a="http://schemas.openxmlformats.org/drawingml/2006/main">
+            <a:off x="800100" y="2419350"/>
+            <a:ext cx="381000" cy="381000"/>
+          </a:xfrm>
+          <a:prstGeom xmlns:a="http://schemas.openxmlformats.org/drawingml/2006/main" prst="ellipse">
+            <a:avLst/>
+          </a:prstGeom>
+          <a:solidFill xmlns:a="http://schemas.openxmlformats.org/drawingml/2006/main">
+            <a:srgbClr val="FFFFFF"/>
+          </a:solidFill>
+          <a:ln xmlns:a="http://schemas.openxmlformats.org/drawingml/2006/main" w="0">
+            <a:noFill/>
+          </a:ln>
+        </p:spPr>
+      </p:sp>
+      <p:sp>
+        <p:nvSpPr>
+          <p:cNvPr id="8" name="">
+            <a:extLst xmlns:a="http://schemas.openxmlformats.org/drawingml/2006/main">
+              <a:ext uri="{FF2B5EF4-FFF2-40B4-BE49-F238E27FC236}">
+                <a16:creationId xmlns:a16="http://schemas.microsoft.com/office/drawing/2014/main" id="{88CC3B34-EF73-4ED5-AC1C-C4940BFD695F}"/>
+              </a:ext>
+            </a:extLst>
+          </p:cNvPr>
+          <p:cNvSpPr>
+            <a:spLocks xmlns:a="http://schemas.openxmlformats.org/drawingml/2006/main" noGrp="1"/>
+          </p:cNvSpPr>
+          <p:nvPr/>
+        </p:nvSpPr>
+        <p:spPr>
+          <a:xfrm xmlns:a="http://schemas.openxmlformats.org/drawingml/2006/main">
+            <a:off x="857250" y="2486025"/>
+            <a:ext cx="342900" cy="285750"/>
+          </a:xfrm>
+          <a:prstGeom xmlns:a="http://schemas.openxmlformats.org/drawingml/2006/main" prst="rect">
+            <a:avLst/>
+          </a:prstGeom>
+          <a:noFill xmlns:a="http://schemas.openxmlformats.org/drawingml/2006/main"/>
+          <a:ln xmlns:a="http://schemas.openxmlformats.org/drawingml/2006/main" w="0">
+            <a:noFill/>
+          </a:ln>
+        </p:spPr>
+        <p:txBody>
+          <a:bodyPr xmlns:a="http://schemas.openxmlformats.org/drawingml/2006/main" lIns="0" tIns="0" rIns="0" bIns="0" anchor="t">
+            <a:noAutofit/>
+          </a:bodyPr>
+          <a:lstStyle xmlns:a="http://schemas.openxmlformats.org/drawingml/2006/main"/>
+          <a:p xmlns:a="http://schemas.openxmlformats.org/drawingml/2006/main">
+            <a:pPr>
+              <a:defRPr sz="1350" b="1">
+                <a:solidFill>
+                  <a:srgbClr val="263C3A"/>
+                </a:solidFill>
+                <a:latin typeface="DejaVu Sans"/>
+                <a:ea typeface="DejaVu Sans"/>
+                <a:cs typeface="DejaVu Sans"/>
+              </a:defRPr>
+            </a:pPr>
+            <a:r>
+              <a:rPr sz="1350" b="1">
+                <a:solidFill>
+                  <a:srgbClr val="263C3A"/>
+                </a:solidFill>
+                <a:latin typeface="DejaVu Sans"/>
+                <a:ea typeface="DejaVu Sans"/>
+                <a:cs typeface="DejaVu Sans"/>
+              </a:rPr>
+              <a:t>01</a:t>
+            </a:r>
+          </a:p>
+        </p:txBody>
+      </p:sp>
+      <p:sp>
+        <p:nvSpPr>
+          <p:cNvPr id="9" name="">
+            <a:extLst xmlns:a="http://schemas.openxmlformats.org/drawingml/2006/main">
+              <a:ext uri="{FF2B5EF4-FFF2-40B4-BE49-F238E27FC236}">
+                <a16:creationId xmlns:a16="http://schemas.microsoft.com/office/drawing/2014/main" id="{8FC3A03E-C751-41C6-BF59-0727B89D1C39}"/>
+              </a:ext>
+            </a:extLst>
+          </p:cNvPr>
+          <p:cNvSpPr>
+            <a:spLocks xmlns:a="http://schemas.openxmlformats.org/drawingml/2006/main" noGrp="1"/>
+          </p:cNvSpPr>
+          <p:nvPr/>
+        </p:nvSpPr>
+        <p:spPr>
+          <a:xfrm xmlns:a="http://schemas.openxmlformats.org/drawingml/2006/main">
+            <a:off x="1352550" y="2466975"/>
+            <a:ext cx="10039350" cy="428625"/>
+          </a:xfrm>
+          <a:prstGeom xmlns:a="http://schemas.openxmlformats.org/drawingml/2006/main" prst="rect">
+            <a:avLst/>
+          </a:prstGeom>
+          <a:noFill xmlns:a="http://schemas.openxmlformats.org/drawingml/2006/main"/>
+          <a:ln xmlns:a="http://schemas.openxmlformats.org/drawingml/2006/main" w="0">
+            <a:noFill/>
+          </a:ln>
+        </p:spPr>
+        <p:txBody>
+          <a:bodyPr xmlns:a="http://schemas.openxmlformats.org/drawingml/2006/main" lIns="0" tIns="0" rIns="0" bIns="0" anchor="t">
+            <a:noAutofit/>
+          </a:bodyPr>
+          <a:lstStyle xmlns:a="http://schemas.openxmlformats.org/drawingml/2006/main"/>
+          <a:p xmlns:a="http://schemas.openxmlformats.org/drawingml/2006/main">
+            <a:pPr>
+              <a:defRPr sz="1725" b="1">
+                <a:solidFill>
+                  <a:srgbClr val="263C3A"/>
+                </a:solidFill>
+                <a:latin typeface="DejaVu Sans"/>
+                <a:ea typeface="DejaVu Sans"/>
+                <a:cs typeface="DejaVu Sans"/>
+              </a:defRPr>
+            </a:pPr>
+            <a:r>
+              <a:rPr sz="1725" b="1">
+                <a:solidFill>
+                  <a:srgbClr val="263C3A"/>
+                </a:solidFill>
+                <a:latin typeface="DejaVu Sans"/>
+                <a:ea typeface="DejaVu Sans"/>
+                <a:cs typeface="DejaVu Sans"/>
+              </a:rPr>
+              <a:t>What can you remember?</a:t>
+            </a:r>
+          </a:p>
+        </p:txBody>
+      </p:sp>
+      <p:sp>
+        <p:nvSpPr>
+          <p:cNvPr id="10" name="">
+            <a:extLst xmlns:a="http://schemas.openxmlformats.org/drawingml/2006/main">
+              <a:ext uri="{FF2B5EF4-FFF2-40B4-BE49-F238E27FC236}">
+                <a16:creationId xmlns:a16="http://schemas.microsoft.com/office/drawing/2014/main" id="{13780980-90CB-4628-9410-19C3F711D5BC}"/>
+              </a:ext>
+            </a:extLst>
+          </p:cNvPr>
+          <p:cNvSpPr>
+            <a:spLocks xmlns:a="http://schemas.openxmlformats.org/drawingml/2006/main" noGrp="1"/>
+          </p:cNvSpPr>
+          <p:nvPr/>
+        </p:nvSpPr>
+        <p:spPr>
+          <a:xfrm xmlns:a="http://schemas.openxmlformats.org/drawingml/2006/main">
+            <a:off x="819150" y="2990850"/>
+            <a:ext cx="10553700" cy="1857375"/>
+          </a:xfrm>
+          <a:prstGeom xmlns:a="http://schemas.openxmlformats.org/drawingml/2006/main" prst="rect">
+            <a:avLst/>
+          </a:prstGeom>
+          <a:noFill xmlns:a="http://schemas.openxmlformats.org/drawingml/2006/main"/>
+          <a:ln xmlns:a="http://schemas.openxmlformats.org/drawingml/2006/main" w="0">
+            <a:noFill/>
+          </a:ln>
+        </p:spPr>
+        <p:txBody>
+          <a:bodyPr xmlns:a="http://schemas.openxmlformats.org/drawingml/2006/main" lIns="0" tIns="0" rIns="0" bIns="0" anchor="t">
+            <a:noAutofit/>
+          </a:bodyPr>
+          <a:lstStyle xmlns:a="http://schemas.openxmlformats.org/drawingml/2006/main"/>
+          <a:p xmlns:a="http://schemas.openxmlformats.org/drawingml/2006/main">
+            <a:pPr>
+              <a:defRPr sz="1950" b="0">
+                <a:solidFill>
+                  <a:srgbClr val="687572"/>
+                </a:solidFill>
+                <a:latin typeface="DejaVu Sans"/>
+                <a:ea typeface="DejaVu Sans"/>
+                <a:cs typeface="DejaVu Sans"/>
+              </a:defRPr>
+            </a:pPr>
+            <a:r>
+              <a:rPr sz="1950" b="0">
+                <a:solidFill>
+                  <a:srgbClr val="687572"/>
+                </a:solidFill>
+                <a:latin typeface="DejaVu Sans"/>
+                <a:ea typeface="DejaVu Sans"/>
+                <a:cs typeface="DejaVu Sans"/>
+              </a:rPr>
+              <a:t>[Your recall focus or headings]</a:t>
+            </a:r>
+          </a:p>
+        </p:txBody>
+      </p:sp>
+      <p:sp>
+        <p:nvSpPr>
+          <p:cNvPr id="11" name="">
+            <a:extLst xmlns:a="http://schemas.openxmlformats.org/drawingml/2006/main">
+              <a:ext uri="{FF2B5EF4-FFF2-40B4-BE49-F238E27FC236}">
+                <a16:creationId xmlns:a16="http://schemas.microsoft.com/office/drawing/2014/main" id="{623A9693-961A-4348-BFFC-EAB37A2C23F3}"/>
+              </a:ext>
+            </a:extLst>
+          </p:cNvPr>
+          <p:cNvSpPr>
+            <a:spLocks xmlns:a="http://schemas.openxmlformats.org/drawingml/2006/main" noGrp="1"/>
+          </p:cNvSpPr>
+          <p:nvPr/>
+        </p:nvSpPr>
+        <p:spPr>
+          <a:xfrm xmlns:a="http://schemas.openxmlformats.org/drawingml/2006/main">
+            <a:off x="609600" y="5267325"/>
+            <a:ext cx="10972800" cy="438150"/>
+          </a:xfrm>
+          <a:prstGeom xmlns:a="http://schemas.openxmlformats.org/drawingml/2006/main" prst="rect">
+            <a:avLst/>
+          </a:prstGeom>
+          <a:noFill xmlns:a="http://schemas.openxmlformats.org/drawingml/2006/main"/>
+          <a:ln xmlns:a="http://schemas.openxmlformats.org/drawingml/2006/main" w="0">
+            <a:noFill/>
+          </a:ln>
+        </p:spPr>
+        <p:txBody>
+          <a:bodyPr xmlns:a="http://schemas.openxmlformats.org/drawingml/2006/main" lIns="0" tIns="0" rIns="0" bIns="0" anchor="t">
+            <a:noAutofit/>
+          </a:bodyPr>
+          <a:lstStyle xmlns:a="http://schemas.openxmlformats.org/drawingml/2006/main"/>
+          <a:p xmlns:a="http://schemas.openxmlformats.org/drawingml/2006/main">
+            <a:pPr>
+              <a:defRPr sz="1950" b="0">
+                <a:solidFill>
+                  <a:srgbClr val="263C3A"/>
+                </a:solidFill>
+                <a:latin typeface="DejaVu Sans"/>
+                <a:ea typeface="DejaVu Sans"/>
+                <a:cs typeface="DejaVu Sans"/>
+              </a:defRPr>
+            </a:pPr>
+            <a:r>
+              <a:rPr sz="1950" b="0">
+                <a:solidFill>
+                  <a:srgbClr val="263C3A"/>
+                </a:solidFill>
+                <a:latin typeface="DejaVu Sans"/>
+                <a:ea typeface="DejaVu Sans"/>
+                <a:cs typeface="DejaVu Sans"/>
+              </a:rPr>
+              <a:t>Write, sketch and connect ideas from memory.</a:t>
+            </a:r>
+          </a:p>
+        </p:txBody>
+      </p:sp>
+      <p:sp>
+        <p:nvSpPr>
+          <p:cNvPr id="12" name="">
+            <a:extLst xmlns:a="http://schemas.openxmlformats.org/drawingml/2006/main">
+              <a:ext uri="{FF2B5EF4-FFF2-40B4-BE49-F238E27FC236}">
+                <a16:creationId xmlns:a16="http://schemas.microsoft.com/office/drawing/2014/main" id="{B298753E-C154-4E25-B1A7-D8820E827B64}"/>
+              </a:ext>
+            </a:extLst>
+          </p:cNvPr>
+          <p:cNvSpPr>
+            <a:spLocks xmlns:a="http://schemas.openxmlformats.org/drawingml/2006/main" noGrp="1"/>
+          </p:cNvSpPr>
+          <p:nvPr/>
+        </p:nvSpPr>
+        <p:spPr>
+          <a:xfrm xmlns:a="http://schemas.openxmlformats.org/drawingml/2006/main">
+            <a:off x="609600" y="5953125"/>
+            <a:ext cx="10972800" cy="9525"/>
+          </a:xfrm>
+          <a:prstGeom xmlns:a="http://schemas.openxmlformats.org/drawingml/2006/main" prst="rect">
+            <a:avLst/>
+          </a:prstGeom>
+          <a:solidFill xmlns:a="http://schemas.openxmlformats.org/drawingml/2006/main">
+            <a:srgbClr val="A9BDB7"/>
+          </a:solidFill>
+          <a:ln xmlns:a="http://schemas.openxmlformats.org/drawingml/2006/main" w="0">
+            <a:noFill/>
+          </a:ln>
+        </p:spPr>
+      </p:sp>
+      <p:sp>
+        <p:nvSpPr>
+          <p:cNvPr id="13" name="">
+            <a:extLst xmlns:a="http://schemas.openxmlformats.org/drawingml/2006/main">
+              <a:ext uri="{FF2B5EF4-FFF2-40B4-BE49-F238E27FC236}">
+                <a16:creationId xmlns:a16="http://schemas.microsoft.com/office/drawing/2014/main" id="{D617C923-E1B3-4F02-8742-8B282ED4819B}"/>
+              </a:ext>
+            </a:extLst>
+          </p:cNvPr>
+          <p:cNvSpPr>
+            <a:spLocks xmlns:a="http://schemas.openxmlformats.org/drawingml/2006/main" noGrp="1"/>
+          </p:cNvSpPr>
+          <p:nvPr/>
+        </p:nvSpPr>
+        <p:spPr>
+          <a:xfrm xmlns:a="http://schemas.openxmlformats.org/drawingml/2006/main">
+            <a:off x="609600" y="6191250"/>
+            <a:ext cx="3238500" cy="361950"/>
+          </a:xfrm>
+          <a:prstGeom xmlns:a="http://schemas.openxmlformats.org/drawingml/2006/main" prst="rect">
+            <a:avLst/>
+          </a:prstGeom>
+          <a:noFill xmlns:a="http://schemas.openxmlformats.org/drawingml/2006/main"/>
+          <a:ln xmlns:a="http://schemas.openxmlformats.org/drawingml/2006/main" w="0">
+            <a:noFill/>
+          </a:ln>
+        </p:spPr>
+        <p:txBody>
+          <a:bodyPr xmlns:a="http://schemas.openxmlformats.org/drawingml/2006/main" lIns="0" tIns="0" rIns="0" bIns="0" anchor="t">
+            <a:noAutofit/>
+          </a:bodyPr>
+          <a:lstStyle xmlns:a="http://schemas.openxmlformats.org/drawingml/2006/main"/>
+          <a:p xmlns:a="http://schemas.openxmlformats.org/drawingml/2006/main">
+            <a:pPr>
+              <a:defRPr sz="1650" b="0">
+                <a:solidFill>
+                  <a:srgbClr val="687572"/>
+                </a:solidFill>
+                <a:latin typeface="DejaVu Sans"/>
+                <a:ea typeface="DejaVu Sans"/>
+                <a:cs typeface="DejaVu Sans"/>
+              </a:defRPr>
+            </a:pPr>
+            <a:r>
+              <a:rPr sz="1650" b="0">
+                <a:solidFill>
+                  <a:srgbClr val="687572"/>
+                </a:solidFill>
+                <a:latin typeface="DejaVu Sans"/>
+                <a:ea typeface="DejaVu Sans"/>
+                <a:cs typeface="DejaVu Sans"/>
+              </a:rPr>
+              <a:t>Time: [Minutes]</a:t>
+            </a:r>
+          </a:p>
+        </p:txBody>
+      </p:sp>
+      <p:sp>
+        <p:nvSpPr>
+          <p:cNvPr id="14" name="">
+            <a:extLst xmlns:a="http://schemas.openxmlformats.org/drawingml/2006/main">
+              <a:ext uri="{FF2B5EF4-FFF2-40B4-BE49-F238E27FC236}">
+                <a16:creationId xmlns:a16="http://schemas.microsoft.com/office/drawing/2014/main" id="{B4084003-8921-4AC2-A698-C2A71C6E72C2}"/>
+              </a:ext>
+            </a:extLst>
+          </p:cNvPr>
+          <p:cNvSpPr>
+            <a:spLocks xmlns:a="http://schemas.openxmlformats.org/drawingml/2006/main" noGrp="1"/>
+          </p:cNvSpPr>
+          <p:nvPr/>
+        </p:nvSpPr>
+        <p:spPr>
+          <a:xfrm xmlns:a="http://schemas.openxmlformats.org/drawingml/2006/main">
+            <a:off x="4286250" y="6191250"/>
+            <a:ext cx="7296150" cy="361950"/>
+          </a:xfrm>
+          <a:prstGeom xmlns:a="http://schemas.openxmlformats.org/drawingml/2006/main" prst="rect">
+            <a:avLst/>
+          </a:prstGeom>
+          <a:noFill xmlns:a="http://schemas.openxmlformats.org/drawingml/2006/main"/>
+          <a:ln xmlns:a="http://schemas.openxmlformats.org/drawingml/2006/main" w="0">
+            <a:noFill/>
+          </a:ln>
+        </p:spPr>
+        <p:txBody>
+          <a:bodyPr xmlns:a="http://schemas.openxmlformats.org/drawingml/2006/main" lIns="0" tIns="0" rIns="0" bIns="0" anchor="t">
+            <a:noAutofit/>
+          </a:bodyPr>
+          <a:lstStyle xmlns:a="http://schemas.openxmlformats.org/drawingml/2006/main"/>
+          <a:p xmlns:a="http://schemas.openxmlformats.org/drawingml/2006/main">
+            <a:pPr>
+              <a:defRPr sz="1650" b="0">
+                <a:solidFill>
+                  <a:srgbClr val="687572"/>
+                </a:solidFill>
+                <a:latin typeface="DejaVu Sans"/>
+                <a:ea typeface="DejaVu Sans"/>
+                <a:cs typeface="DejaVu Sans"/>
+              </a:defRPr>
+            </a:pPr>
+            <a:r>
+              <a:rPr sz="1650" b="0">
+                <a:solidFill>
+                  <a:srgbClr val="687572"/>
+                </a:solidFill>
+                <a:latin typeface="DejaVu Sans"/>
+                <a:ea typeface="DejaVu Sans"/>
+                <a:cs typeface="DejaVu Sans"/>
+              </a:rPr>
+              <a:t>Feedback: [Your checking routine]</a:t>
             </a:r>
           </a:p>
         </p:txBody>
@@ -3253,7 +3521,7 @@
     </p:spTree>
     <p:extLst>
       <p:ext uri="{BB962C8B-B14F-4D97-AF65-F5344CB8AC3E}">
-        <p14:creationId xmlns:p14="http://schemas.microsoft.com/office/powerpoint/2010/main" val="2055856874"/>
+        <p14:creationId xmlns:p14="http://schemas.microsoft.com/office/powerpoint/2010/main" val="987474474"/>
       </p:ext>
     </p:extLst>
   </p:cSld>

</xml_diff>